<commit_message>
behaved optimizer although constrained, good first candidate for training
</commit_message>
<xml_diff>
--- a/documentation/Meeting 3.pptx
+++ b/documentation/Meeting 3.pptx
@@ -5,18 +5,19 @@
     <p:sldMasterId id="2147483648" r:id="rId1"/>
   </p:sldMasterIdLst>
   <p:notesMasterIdLst>
-    <p:notesMasterId r:id="rId11"/>
+    <p:notesMasterId r:id="rId12"/>
   </p:notesMasterIdLst>
   <p:sldIdLst>
     <p:sldId id="256" r:id="rId2"/>
     <p:sldId id="257" r:id="rId3"/>
     <p:sldId id="269" r:id="rId4"/>
     <p:sldId id="272" r:id="rId5"/>
-    <p:sldId id="271" r:id="rId6"/>
-    <p:sldId id="258" r:id="rId7"/>
-    <p:sldId id="268" r:id="rId8"/>
-    <p:sldId id="270" r:id="rId9"/>
-    <p:sldId id="267" r:id="rId10"/>
+    <p:sldId id="273" r:id="rId6"/>
+    <p:sldId id="271" r:id="rId7"/>
+    <p:sldId id="258" r:id="rId8"/>
+    <p:sldId id="268" r:id="rId9"/>
+    <p:sldId id="270" r:id="rId10"/>
+    <p:sldId id="267" r:id="rId11"/>
   </p:sldIdLst>
   <p:sldSz cx="12192000" cy="6858000"/>
   <p:notesSz cx="6858000" cy="9144000"/>
@@ -1627,6 +1628,175 @@
 </p:notes>
 </file>
 
+<file path=ppt/notesSlides/notesSlide10.xml><?xml version="1.0" encoding="utf-8"?>
+<p:notes xmlns:a="http://schemas.openxmlformats.org/drawingml/2006/main" xmlns:r="http://schemas.openxmlformats.org/officeDocument/2006/relationships" xmlns:p="http://schemas.openxmlformats.org/presentationml/2006/main" showMasterSp="0" showMasterPhAnim="0">
+  <p:cSld>
+    <p:spTree>
+      <p:nvGrpSpPr>
+        <p:cNvPr id="1" name="Shape 174"/>
+        <p:cNvGrpSpPr/>
+        <p:nvPr/>
+      </p:nvGrpSpPr>
+      <p:grpSpPr>
+        <a:xfrm>
+          <a:off x="0" y="0"/>
+          <a:ext cx="0" cy="0"/>
+          <a:chOff x="0" y="0"/>
+          <a:chExt cx="0" cy="0"/>
+        </a:xfrm>
+      </p:grpSpPr>
+      <p:sp>
+        <p:nvSpPr>
+          <p:cNvPr id="175" name="Google Shape;175;p14:notes"/>
+          <p:cNvSpPr>
+            <a:spLocks noGrp="1" noRot="1" noChangeAspect="1"/>
+          </p:cNvSpPr>
+          <p:nvPr>
+            <p:ph type="sldImg" idx="2"/>
+          </p:nvPr>
+        </p:nvSpPr>
+        <p:spPr>
+          <a:xfrm>
+            <a:off x="685800" y="1143000"/>
+            <a:ext cx="5486400" cy="3086100"/>
+          </a:xfrm>
+          <a:custGeom>
+            <a:avLst/>
+            <a:gdLst/>
+            <a:ahLst/>
+            <a:cxnLst/>
+            <a:rect l="l" t="t" r="r" b="b"/>
+            <a:pathLst>
+              <a:path w="120000" h="120000" extrusionOk="0">
+                <a:moveTo>
+                  <a:pt x="0" y="0"/>
+                </a:moveTo>
+                <a:lnTo>
+                  <a:pt x="120000" y="0"/>
+                </a:lnTo>
+                <a:lnTo>
+                  <a:pt x="120000" y="120000"/>
+                </a:lnTo>
+                <a:lnTo>
+                  <a:pt x="0" y="120000"/>
+                </a:lnTo>
+                <a:close/>
+              </a:path>
+            </a:pathLst>
+          </a:custGeom>
+          <a:noFill/>
+          <a:ln w="12700" cap="flat" cmpd="sng">
+            <a:solidFill>
+              <a:srgbClr val="000000"/>
+            </a:solidFill>
+            <a:prstDash val="solid"/>
+            <a:round/>
+            <a:headEnd type="none" w="sm" len="sm"/>
+            <a:tailEnd type="none" w="sm" len="sm"/>
+          </a:ln>
+        </p:spPr>
+      </p:sp>
+      <p:sp>
+        <p:nvSpPr>
+          <p:cNvPr id="176" name="Google Shape;176;p14:notes"/>
+          <p:cNvSpPr txBox="1">
+            <a:spLocks noGrp="1"/>
+          </p:cNvSpPr>
+          <p:nvPr>
+            <p:ph type="body" idx="1"/>
+          </p:nvPr>
+        </p:nvSpPr>
+        <p:spPr>
+          <a:xfrm>
+            <a:off x="685800" y="4400550"/>
+            <a:ext cx="5486400" cy="3600450"/>
+          </a:xfrm>
+          <a:prstGeom prst="rect">
+            <a:avLst/>
+          </a:prstGeom>
+          <a:noFill/>
+          <a:ln>
+            <a:noFill/>
+          </a:ln>
+        </p:spPr>
+        <p:txBody>
+          <a:bodyPr spcFirstLastPara="1" wrap="square" lIns="91425" tIns="45700" rIns="91425" bIns="45700" anchor="t" anchorCtr="0">
+            <a:noAutofit/>
+          </a:bodyPr>
+          <a:lstStyle/>
+          <a:p>
+            <a:pPr marL="0" lvl="0" indent="0" algn="l" rtl="0">
+              <a:spcBef>
+                <a:spcPts val="0"/>
+              </a:spcBef>
+              <a:spcAft>
+                <a:spcPts val="0"/>
+              </a:spcAft>
+              <a:buNone/>
+            </a:pPr>
+            <a:endParaRPr/>
+          </a:p>
+        </p:txBody>
+      </p:sp>
+      <p:sp>
+        <p:nvSpPr>
+          <p:cNvPr id="177" name="Google Shape;177;p14:notes"/>
+          <p:cNvSpPr txBox="1">
+            <a:spLocks noGrp="1"/>
+          </p:cNvSpPr>
+          <p:nvPr>
+            <p:ph type="sldNum" idx="12"/>
+          </p:nvPr>
+        </p:nvSpPr>
+        <p:spPr>
+          <a:xfrm>
+            <a:off x="3884613" y="8685213"/>
+            <a:ext cx="2971800" cy="458787"/>
+          </a:xfrm>
+          <a:prstGeom prst="rect">
+            <a:avLst/>
+          </a:prstGeom>
+          <a:noFill/>
+          <a:ln>
+            <a:noFill/>
+          </a:ln>
+        </p:spPr>
+        <p:txBody>
+          <a:bodyPr spcFirstLastPara="1" wrap="square" lIns="91425" tIns="45700" rIns="91425" bIns="45700" anchor="b" anchorCtr="0">
+            <a:noAutofit/>
+          </a:bodyPr>
+          <a:lstStyle/>
+          <a:p>
+            <a:pPr marL="0" lvl="0" indent="0" algn="r" rtl="0">
+              <a:spcBef>
+                <a:spcPts val="0"/>
+              </a:spcBef>
+              <a:spcAft>
+                <a:spcPts val="0"/>
+              </a:spcAft>
+              <a:buNone/>
+            </a:pPr>
+            <a:fld id="{00000000-1234-1234-1234-123412341234}" type="slidenum">
+              <a:rPr lang="it-IT"/>
+              <a:t>10</a:t>
+            </a:fld>
+            <a:endParaRPr/>
+          </a:p>
+        </p:txBody>
+      </p:sp>
+    </p:spTree>
+    <p:extLst>
+      <p:ext uri="{BB962C8B-B14F-4D97-AF65-F5344CB8AC3E}">
+        <p14:creationId xmlns:p14="http://schemas.microsoft.com/office/powerpoint/2010/main" val="2109531916"/>
+      </p:ext>
+    </p:extLst>
+  </p:cSld>
+  <p:clrMapOvr>
+    <a:masterClrMapping/>
+  </p:clrMapOvr>
+</p:notes>
+</file>
+
 <file path=ppt/notesSlides/notesSlide2.xml><?xml version="1.0" encoding="utf-8"?>
 <p:notes xmlns:a="http://schemas.openxmlformats.org/drawingml/2006/main" xmlns:r="http://schemas.openxmlformats.org/officeDocument/2006/relationships" xmlns:p="http://schemas.openxmlformats.org/presentationml/2006/main" showMasterSp="0" showMasterPhAnim="0">
   <p:cSld>
@@ -3077,7 +3247,7 @@
     </p:spTree>
     <p:extLst>
       <p:ext uri="{BB962C8B-B14F-4D97-AF65-F5344CB8AC3E}">
-        <p14:creationId xmlns:p14="http://schemas.microsoft.com/office/powerpoint/2010/main" val="2470809622"/>
+        <p14:creationId xmlns:p14="http://schemas.microsoft.com/office/powerpoint/2010/main" val="1762089833"/>
       </p:ext>
     </p:extLst>
   </p:cSld>
@@ -3092,7 +3262,7 @@
   <p:cSld>
     <p:spTree>
       <p:nvGrpSpPr>
-        <p:cNvPr id="1" name="Shape 106"/>
+        <p:cNvPr id="1" name="Shape 99"/>
         <p:cNvGrpSpPr/>
         <p:nvPr/>
       </p:nvGrpSpPr>
@@ -3106,7 +3276,7 @@
       </p:grpSpPr>
       <p:sp>
         <p:nvSpPr>
-          <p:cNvPr id="107" name="Google Shape;107;p3:notes"/>
+          <p:cNvPr id="100" name="Google Shape;100;p2:notes"/>
           <p:cNvSpPr>
             <a:spLocks noGrp="1" noRot="1" noChangeAspect="1"/>
           </p:cNvSpPr>
@@ -3157,7 +3327,7 @@
       </p:sp>
       <p:sp>
         <p:nvSpPr>
-          <p:cNvPr id="108" name="Google Shape;108;p3:notes"/>
+          <p:cNvPr id="101" name="Google Shape;101;p2:notes"/>
           <p:cNvSpPr txBox="1">
             <a:spLocks noGrp="1"/>
           </p:cNvSpPr>
@@ -3194,8 +3364,200 @@
               <a:buNone/>
             </a:pPr>
             <a:r>
-              <a:rPr lang="it-IT"/>
-              <a:t>Utilizzare sempre i modelli di elenco forniti dal programma, quindi non realizzare elenchi solamente inserendo trattini, numeri o punti, affinché una sintesi vocale possa leggerli in ordine e proprio come elenchi.</a:t>
+              <a:rPr lang="it-IT" sz="1200" b="0" i="0" u="none" strike="noStrike">
+                <a:solidFill>
+                  <a:schemeClr val="dk1"/>
+                </a:solidFill>
+                <a:latin typeface="Calibri"/>
+                <a:ea typeface="Calibri"/>
+                <a:cs typeface="Calibri"/>
+                <a:sym typeface="Calibri"/>
+              </a:rPr>
+              <a:t>Preferire un carattere sans serif come Arial, Helvetica o Verdana. Font consigliabile da 30 a 40 pt.</a:t>
+            </a:r>
+            <a:endParaRPr/>
+          </a:p>
+          <a:p>
+            <a:pPr marL="0" marR="0" lvl="0" indent="0" algn="l" rtl="0">
+              <a:lnSpc>
+                <a:spcPct val="100000"/>
+              </a:lnSpc>
+              <a:spcBef>
+                <a:spcPts val="0"/>
+              </a:spcBef>
+              <a:spcAft>
+                <a:spcPts val="0"/>
+              </a:spcAft>
+              <a:buClr>
+                <a:schemeClr val="dk1"/>
+              </a:buClr>
+              <a:buSzPts val="1200"/>
+              <a:buFont typeface="Calibri"/>
+              <a:buNone/>
+            </a:pPr>
+            <a:r>
+              <a:rPr lang="it-IT" sz="1200" b="0" i="0" u="none" strike="noStrike">
+                <a:solidFill>
+                  <a:schemeClr val="dk1"/>
+                </a:solidFill>
+                <a:latin typeface="Calibri"/>
+                <a:ea typeface="Calibri"/>
+                <a:cs typeface="Calibri"/>
+                <a:sym typeface="Calibri"/>
+              </a:rPr>
+              <a:t>Allineare i testi a sinistra, non giustificarli. </a:t>
+            </a:r>
+            <a:endParaRPr/>
+          </a:p>
+          <a:p>
+            <a:pPr marL="0" marR="0" lvl="0" indent="0" algn="l" rtl="0">
+              <a:lnSpc>
+                <a:spcPct val="100000"/>
+              </a:lnSpc>
+              <a:spcBef>
+                <a:spcPts val="0"/>
+              </a:spcBef>
+              <a:spcAft>
+                <a:spcPts val="0"/>
+              </a:spcAft>
+              <a:buClr>
+                <a:schemeClr val="dk1"/>
+              </a:buClr>
+              <a:buSzPts val="1200"/>
+              <a:buFont typeface="Calibri"/>
+              <a:buNone/>
+            </a:pPr>
+            <a:r>
+              <a:rPr lang="it-IT" sz="1200" b="0" i="0" u="none" strike="noStrike">
+                <a:solidFill>
+                  <a:schemeClr val="dk1"/>
+                </a:solidFill>
+                <a:latin typeface="Calibri"/>
+                <a:ea typeface="Calibri"/>
+                <a:cs typeface="Calibri"/>
+                <a:sym typeface="Calibri"/>
+              </a:rPr>
+              <a:t>Utilizzare non più di tre blocchi di informazione di massimo 2/3 righe ciascuno.</a:t>
+            </a:r>
+            <a:endParaRPr/>
+          </a:p>
+          <a:p>
+            <a:pPr marL="0" lvl="0" indent="0" algn="l" rtl="0">
+              <a:spcBef>
+                <a:spcPts val="0"/>
+              </a:spcBef>
+              <a:spcAft>
+                <a:spcPts val="0"/>
+              </a:spcAft>
+              <a:buNone/>
+            </a:pPr>
+            <a:r>
+              <a:rPr lang="it-IT" sz="1200" b="0" i="0" u="none" strike="noStrike">
+                <a:solidFill>
+                  <a:schemeClr val="dk1"/>
+                </a:solidFill>
+                <a:latin typeface="Calibri"/>
+                <a:ea typeface="Calibri"/>
+                <a:cs typeface="Calibri"/>
+                <a:sym typeface="Calibri"/>
+              </a:rPr>
+              <a:t>Per evidenziare titoli o parole chiave, prediligere l’uso del grassetto a corsivo o colori. </a:t>
+            </a:r>
+            <a:endParaRPr sz="1200" b="0" i="0" u="none" strike="noStrike">
+              <a:solidFill>
+                <a:schemeClr val="dk1"/>
+              </a:solidFill>
+              <a:latin typeface="Calibri"/>
+              <a:ea typeface="Calibri"/>
+              <a:cs typeface="Calibri"/>
+              <a:sym typeface="Calibri"/>
+            </a:endParaRPr>
+          </a:p>
+          <a:p>
+            <a:pPr marL="0" marR="0" lvl="0" indent="0" algn="l" rtl="0">
+              <a:lnSpc>
+                <a:spcPct val="100000"/>
+              </a:lnSpc>
+              <a:spcBef>
+                <a:spcPts val="0"/>
+              </a:spcBef>
+              <a:spcAft>
+                <a:spcPts val="0"/>
+              </a:spcAft>
+              <a:buClr>
+                <a:schemeClr val="dk1"/>
+              </a:buClr>
+              <a:buSzPts val="1200"/>
+              <a:buFont typeface="Calibri"/>
+              <a:buNone/>
+            </a:pPr>
+            <a:r>
+              <a:rPr lang="it-IT" sz="1200" b="0" i="0" u="none" strike="noStrike">
+                <a:solidFill>
+                  <a:schemeClr val="dk1"/>
+                </a:solidFill>
+                <a:latin typeface="Calibri"/>
+                <a:ea typeface="Calibri"/>
+                <a:cs typeface="Calibri"/>
+                <a:sym typeface="Calibri"/>
+              </a:rPr>
+              <a:t>Prediligere testo nero su sfondo bianco.</a:t>
+            </a:r>
+            <a:endParaRPr sz="1200" b="0" i="0" u="none" strike="noStrike">
+              <a:solidFill>
+                <a:schemeClr val="dk1"/>
+              </a:solidFill>
+              <a:latin typeface="Calibri"/>
+              <a:ea typeface="Calibri"/>
+              <a:cs typeface="Calibri"/>
+              <a:sym typeface="Calibri"/>
+            </a:endParaRPr>
+          </a:p>
+          <a:p>
+            <a:pPr marL="0" lvl="0" indent="0" algn="l" rtl="0">
+              <a:spcBef>
+                <a:spcPts val="0"/>
+              </a:spcBef>
+              <a:spcAft>
+                <a:spcPts val="0"/>
+              </a:spcAft>
+              <a:buNone/>
+            </a:pPr>
+            <a:r>
+              <a:rPr lang="it-IT" sz="1200" b="0" i="0" u="none" strike="noStrike">
+                <a:solidFill>
+                  <a:schemeClr val="dk1"/>
+                </a:solidFill>
+                <a:latin typeface="Calibri"/>
+                <a:ea typeface="Calibri"/>
+                <a:cs typeface="Calibri"/>
+                <a:sym typeface="Calibri"/>
+              </a:rPr>
+              <a:t>Evitare ombre, sfumature e gradazioni di grigio.</a:t>
+            </a:r>
+            <a:endParaRPr/>
+          </a:p>
+          <a:p>
+            <a:pPr marL="0" lvl="0" indent="0" algn="l" rtl="0">
+              <a:spcBef>
+                <a:spcPts val="0"/>
+              </a:spcBef>
+              <a:spcAft>
+                <a:spcPts val="0"/>
+              </a:spcAft>
+              <a:buNone/>
+            </a:pPr>
+            <a:r>
+              <a:rPr lang="it-IT" sz="1200" b="0" i="0" u="none" strike="noStrike">
+                <a:solidFill>
+                  <a:schemeClr val="dk1"/>
+                </a:solidFill>
+                <a:latin typeface="Calibri"/>
+                <a:ea typeface="Calibri"/>
+                <a:cs typeface="Calibri"/>
+                <a:sym typeface="Calibri"/>
+              </a:rPr>
+              <a:t>Secondo le linee guida sull’accessibilità, prestare attenzione ai contrasti tra i colori di sfondo e il testo.</a:t>
             </a:r>
             <a:endParaRPr/>
           </a:p>
@@ -3203,7 +3565,7 @@
       </p:sp>
       <p:sp>
         <p:nvSpPr>
-          <p:cNvPr id="109" name="Google Shape;109;p3:notes"/>
+          <p:cNvPr id="102" name="Google Shape;102;p2:notes"/>
           <p:cNvSpPr txBox="1">
             <a:spLocks noGrp="1"/>
           </p:cNvSpPr>
@@ -3250,7 +3612,7 @@
     </p:spTree>
     <p:extLst>
       <p:ext uri="{BB962C8B-B14F-4D97-AF65-F5344CB8AC3E}">
-        <p14:creationId xmlns:p14="http://schemas.microsoft.com/office/powerpoint/2010/main" val="62570394"/>
+        <p14:creationId xmlns:p14="http://schemas.microsoft.com/office/powerpoint/2010/main" val="2470809622"/>
       </p:ext>
     </p:extLst>
   </p:cSld>
@@ -3423,7 +3785,7 @@
     </p:spTree>
     <p:extLst>
       <p:ext uri="{BB962C8B-B14F-4D97-AF65-F5344CB8AC3E}">
-        <p14:creationId xmlns:p14="http://schemas.microsoft.com/office/powerpoint/2010/main" val="1428798531"/>
+        <p14:creationId xmlns:p14="http://schemas.microsoft.com/office/powerpoint/2010/main" val="62570394"/>
       </p:ext>
     </p:extLst>
   </p:cSld>
@@ -3596,7 +3958,7 @@
     </p:spTree>
     <p:extLst>
       <p:ext uri="{BB962C8B-B14F-4D97-AF65-F5344CB8AC3E}">
-        <p14:creationId xmlns:p14="http://schemas.microsoft.com/office/powerpoint/2010/main" val="3608255539"/>
+        <p14:creationId xmlns:p14="http://schemas.microsoft.com/office/powerpoint/2010/main" val="1428798531"/>
       </p:ext>
     </p:extLst>
   </p:cSld>
@@ -3611,7 +3973,7 @@
   <p:cSld>
     <p:spTree>
       <p:nvGrpSpPr>
-        <p:cNvPr id="1" name="Shape 174"/>
+        <p:cNvPr id="1" name="Shape 106"/>
         <p:cNvGrpSpPr/>
         <p:nvPr/>
       </p:nvGrpSpPr>
@@ -3625,7 +3987,7 @@
       </p:grpSpPr>
       <p:sp>
         <p:nvSpPr>
-          <p:cNvPr id="175" name="Google Shape;175;p14:notes"/>
+          <p:cNvPr id="107" name="Google Shape;107;p3:notes"/>
           <p:cNvSpPr>
             <a:spLocks noGrp="1" noRot="1" noChangeAspect="1"/>
           </p:cNvSpPr>
@@ -3676,7 +4038,7 @@
       </p:sp>
       <p:sp>
         <p:nvSpPr>
-          <p:cNvPr id="176" name="Google Shape;176;p14:notes"/>
+          <p:cNvPr id="108" name="Google Shape;108;p3:notes"/>
           <p:cNvSpPr txBox="1">
             <a:spLocks noGrp="1"/>
           </p:cNvSpPr>
@@ -3712,13 +4074,17 @@
               </a:spcAft>
               <a:buNone/>
             </a:pPr>
+            <a:r>
+              <a:rPr lang="it-IT"/>
+              <a:t>Utilizzare sempre i modelli di elenco forniti dal programma, quindi non realizzare elenchi solamente inserendo trattini, numeri o punti, affinché una sintesi vocale possa leggerli in ordine e proprio come elenchi.</a:t>
+            </a:r>
             <a:endParaRPr/>
           </a:p>
         </p:txBody>
       </p:sp>
       <p:sp>
         <p:nvSpPr>
-          <p:cNvPr id="177" name="Google Shape;177;p14:notes"/>
+          <p:cNvPr id="109" name="Google Shape;109;p3:notes"/>
           <p:cNvSpPr txBox="1">
             <a:spLocks noGrp="1"/>
           </p:cNvSpPr>
@@ -3765,7 +4131,7 @@
     </p:spTree>
     <p:extLst>
       <p:ext uri="{BB962C8B-B14F-4D97-AF65-F5344CB8AC3E}">
-        <p14:creationId xmlns:p14="http://schemas.microsoft.com/office/powerpoint/2010/main" val="2109531916"/>
+        <p14:creationId xmlns:p14="http://schemas.microsoft.com/office/powerpoint/2010/main" val="3608255539"/>
       </p:ext>
     </p:extLst>
   </p:cSld>
@@ -14585,6 +14951,85 @@
 </p:sld>
 </file>
 
+<file path=ppt/slides/slide10.xml><?xml version="1.0" encoding="utf-8"?>
+<p:sld xmlns:a="http://schemas.openxmlformats.org/drawingml/2006/main" xmlns:r="http://schemas.openxmlformats.org/officeDocument/2006/relationships" xmlns:p="http://schemas.openxmlformats.org/presentationml/2006/main">
+  <p:cSld>
+    <p:spTree>
+      <p:nvGrpSpPr>
+        <p:cNvPr id="1" name="Shape 178"/>
+        <p:cNvGrpSpPr/>
+        <p:nvPr/>
+      </p:nvGrpSpPr>
+      <p:grpSpPr>
+        <a:xfrm>
+          <a:off x="0" y="0"/>
+          <a:ext cx="0" cy="0"/>
+          <a:chOff x="0" y="0"/>
+          <a:chExt cx="0" cy="0"/>
+        </a:xfrm>
+      </p:grpSpPr>
+      <p:sp>
+        <p:nvSpPr>
+          <p:cNvPr id="179" name="Google Shape;179;p14"/>
+          <p:cNvSpPr txBox="1">
+            <a:spLocks noGrp="1"/>
+          </p:cNvSpPr>
+          <p:nvPr>
+            <p:ph type="title" idx="4294967295"/>
+          </p:nvPr>
+        </p:nvSpPr>
+        <p:spPr>
+          <a:xfrm>
+            <a:off x="838200" y="-1325563"/>
+            <a:ext cx="10515600" cy="1325563"/>
+          </a:xfrm>
+          <a:prstGeom prst="rect">
+            <a:avLst/>
+          </a:prstGeom>
+          <a:noFill/>
+          <a:ln>
+            <a:noFill/>
+          </a:ln>
+        </p:spPr>
+        <p:txBody>
+          <a:bodyPr spcFirstLastPara="1" wrap="square" lIns="91425" tIns="45700" rIns="91425" bIns="45700" anchor="b" anchorCtr="0">
+            <a:normAutofit/>
+          </a:bodyPr>
+          <a:lstStyle/>
+          <a:p>
+            <a:pPr marL="0" lvl="0" indent="0" algn="ctr" rtl="0">
+              <a:lnSpc>
+                <a:spcPct val="90000"/>
+              </a:lnSpc>
+              <a:spcBef>
+                <a:spcPts val="0"/>
+              </a:spcBef>
+              <a:spcAft>
+                <a:spcPts val="0"/>
+              </a:spcAft>
+              <a:buClr>
+                <a:schemeClr val="dk1"/>
+              </a:buClr>
+              <a:buSzPts val="4400"/>
+              <a:buFont typeface="Arial"/>
+              <a:buNone/>
+            </a:pPr>
+            <a:r>
+              <a:rPr lang="it-IT"/>
+              <a:t>Università degli Studi di Padova</a:t>
+            </a:r>
+            <a:endParaRPr/>
+          </a:p>
+        </p:txBody>
+      </p:sp>
+    </p:spTree>
+  </p:cSld>
+  <p:clrMapOvr>
+    <a:masterClrMapping/>
+  </p:clrMapOvr>
+</p:sld>
+</file>
+
 <file path=ppt/slides/slide2.xml><?xml version="1.0" encoding="utf-8"?>
 <p:sld xmlns:a="http://schemas.openxmlformats.org/drawingml/2006/main" xmlns:r="http://schemas.openxmlformats.org/officeDocument/2006/relationships" xmlns:p="http://schemas.openxmlformats.org/presentationml/2006/main">
   <p:cSld>
@@ -14690,15 +15135,7 @@
             </a:pPr>
             <a:r>
               <a:rPr lang="en-US" dirty="0" smtClean="0"/>
-              <a:t>I </a:t>
-            </a:r>
-            <a:r>
-              <a:rPr lang="en-US" dirty="0" smtClean="0"/>
-              <a:t>was able </a:t>
-            </a:r>
-            <a:r>
-              <a:rPr lang="en-US" dirty="0" smtClean="0"/>
-              <a:t>to replicate most of Sofia’s thesis results</a:t>
+              <a:t>I was able to replicate most of Sofia’s thesis results</a:t>
             </a:r>
           </a:p>
           <a:p>
@@ -14911,7 +15348,6 @@
               <a:rPr lang="en-US" dirty="0" smtClean="0"/>
               <a:t>Decentralization: each drone takes its own decisions. No need for communication or synching</a:t>
             </a:r>
-            <a:endParaRPr lang="en-US" dirty="0" smtClean="0"/>
           </a:p>
           <a:p>
             <a:pPr marL="0" indent="0">
@@ -14935,11 +15371,7 @@
             </a:pPr>
             <a:r>
               <a:rPr lang="en-US" dirty="0" smtClean="0"/>
-              <a:t>Optimizer: </a:t>
-            </a:r>
-            <a:r>
-              <a:rPr lang="en-US" dirty="0" smtClean="0"/>
-              <a:t>~3-4 ms/step (on my laptop)*</a:t>
+              <a:t>Optimizer: ~3-4 ms/step (on my laptop)*</a:t>
             </a:r>
           </a:p>
           <a:p>
@@ -14998,7 +15430,6 @@
               <a:rPr lang="en-US" sz="1400" dirty="0" smtClean="0"/>
               <a:t>overhead</a:t>
             </a:r>
-            <a:endParaRPr lang="en-US" sz="1400" dirty="0" smtClean="0"/>
           </a:p>
         </p:txBody>
       </p:sp>
@@ -15080,7 +15511,22 @@
             </a:pPr>
             <a:r>
               <a:rPr lang="it-IT" dirty="0" smtClean="0"/>
-              <a:t>Candidate RL architectures/Formulations</a:t>
+              <a:t>Candidate RL </a:t>
+            </a:r>
+            <a:r>
+              <a:rPr lang="it-IT" dirty="0" smtClean="0"/>
+              <a:t>architectures/Formulations</a:t>
+            </a:r>
+            <a:r>
+              <a:rPr lang="ar-EG" dirty="0"/>
+              <a:t/>
+            </a:r>
+            <a:br>
+              <a:rPr lang="ar-EG" dirty="0"/>
+            </a:br>
+            <a:r>
+              <a:rPr lang="en-US" dirty="0" smtClean="0"/>
+              <a:t>Formulation 1:</a:t>
             </a:r>
             <a:endParaRPr dirty="0"/>
           </a:p>
@@ -15099,7 +15545,7 @@
         <p:spPr>
           <a:xfrm>
             <a:off x="455999" y="2178768"/>
-            <a:ext cx="11385933" cy="4181291"/>
+            <a:ext cx="11385933" cy="4520796"/>
           </a:xfrm>
           <a:prstGeom prst="rect">
             <a:avLst/>
@@ -15111,7 +15557,7 @@
         </p:spPr>
         <p:txBody>
           <a:bodyPr spcFirstLastPara="1" wrap="square" lIns="91425" tIns="45700" rIns="91425" bIns="45700" anchor="t" anchorCtr="0">
-            <a:normAutofit lnSpcReduction="10000"/>
+            <a:normAutofit fontScale="85000" lnSpcReduction="10000"/>
           </a:bodyPr>
           <a:lstStyle/>
           <a:p>
@@ -15120,8 +15566,25 @@
             </a:pPr>
             <a:r>
               <a:rPr lang="en-US" dirty="0" smtClean="0"/>
-              <a:t>Action Space: Internal forces only(and their derivatives). </a:t>
-            </a:r>
+              <a:t>Action </a:t>
+            </a:r>
+            <a:r>
+              <a:rPr lang="en-US" dirty="0" smtClean="0"/>
+              <a:t>Space: </a:t>
+            </a:r>
+            <a:r>
+              <a:rPr lang="el-GR" dirty="0"/>
+              <a:t>λ ∈ </a:t>
+            </a:r>
+            <a:r>
+              <a:rPr lang="en-US" dirty="0" err="1" smtClean="0"/>
+              <a:t>R</a:t>
+            </a:r>
+            <a:r>
+              <a:rPr lang="en-US" baseline="30000" dirty="0" err="1" smtClean="0"/>
+              <a:t>n</a:t>
+            </a:r>
+            <a:endParaRPr lang="en-US" baseline="30000" dirty="0" smtClean="0"/>
           </a:p>
           <a:p>
             <a:pPr lvl="1" indent="-457200">
@@ -15129,7 +15592,15 @@
             </a:pPr>
             <a:r>
               <a:rPr lang="en-US" dirty="0" smtClean="0"/>
-              <a:t>Keep wrench controller</a:t>
+              <a:t>Keep wrench controller and </a:t>
+            </a:r>
+            <a:r>
+              <a:rPr lang="en-US" dirty="0" err="1" smtClean="0"/>
+              <a:t>nullspace</a:t>
+            </a:r>
+            <a:r>
+              <a:rPr lang="en-US" dirty="0" smtClean="0"/>
+              <a:t> matrix. Run decentralized</a:t>
             </a:r>
           </a:p>
           <a:p>
@@ -15163,8 +15634,60 @@
             </a:r>
             <a:r>
               <a:rPr lang="en-US" u="sng" dirty="0"/>
-              <a:t>(𝑡),</a:t>
-            </a:r>
+              <a:t>(𝑡</a:t>
+            </a:r>
+            <a:r>
+              <a:rPr lang="en-US" u="sng" dirty="0" smtClean="0"/>
+              <a:t>),</a:t>
+            </a:r>
+          </a:p>
+          <a:p>
+            <a:pPr marL="457200" lvl="1" indent="0">
+              <a:buSzPts val="3200"/>
+              <a:buNone/>
+            </a:pPr>
+            <a:r>
+              <a:rPr lang="en-US" dirty="0"/>
+              <a:t>𝑓</a:t>
+            </a:r>
+            <a:r>
+              <a:rPr lang="en-US" baseline="-25000" dirty="0"/>
+              <a:t>𝜆</a:t>
+            </a:r>
+            <a:r>
+              <a:rPr lang="en-US" dirty="0"/>
+              <a:t>(𝑡)</a:t>
+            </a:r>
+            <a:r>
+              <a:rPr lang="en-US" dirty="0" smtClean="0"/>
+              <a:t>= </a:t>
+            </a:r>
+            <a:r>
+              <a:rPr lang="en-US" dirty="0"/>
+              <a:t>N(</a:t>
+            </a:r>
+            <a:r>
+              <a:rPr lang="en-US" dirty="0" err="1"/>
+              <a:t>H,t</a:t>
+            </a:r>
+            <a:r>
+              <a:rPr lang="en-US" dirty="0"/>
+              <a:t>) · </a:t>
+            </a:r>
+            <a:r>
+              <a:rPr lang="el-GR" u="sng" dirty="0"/>
+              <a:t>λ(</a:t>
+            </a:r>
+            <a:r>
+              <a:rPr lang="en-US" u="sng" dirty="0"/>
+              <a:t>t)</a:t>
+            </a:r>
+          </a:p>
+          <a:p>
+            <a:pPr marL="457200" lvl="1" indent="0">
+              <a:buSzPts val="3200"/>
+              <a:buNone/>
+            </a:pPr>
             <a:endParaRPr lang="en-US" u="sng" dirty="0" smtClean="0"/>
           </a:p>
           <a:p>
@@ -15186,15 +15709,27 @@
             </a:pPr>
             <a:r>
               <a:rPr lang="en-US" dirty="0"/>
-              <a:t>Punish for velocity magnitude &lt; </a:t>
+              <a:t>Penalize ‖</a:t>
+            </a:r>
+            <a:r>
+              <a:rPr lang="en-US" dirty="0" err="1"/>
+              <a:t>ṗRi</a:t>
+            </a:r>
+            <a:r>
+              <a:rPr lang="en-US" dirty="0"/>
+              <a:t>‖ &lt; </a:t>
             </a:r>
             <a:r>
               <a:rPr lang="el-GR" dirty="0"/>
               <a:t>ε</a:t>
             </a:r>
             <a:r>
+              <a:rPr lang="en-US" dirty="0" smtClean="0"/>
+              <a:t> </a:t>
+            </a:r>
+            <a:r>
               <a:rPr lang="en-US" dirty="0"/>
-              <a:t> (would be interesting to see if agent comes up with the same strategy)</a:t>
+              <a:t>(would be interesting to see if agent comes up with the same strategy)</a:t>
             </a:r>
           </a:p>
           <a:p>
@@ -15203,7 +15738,11 @@
             </a:pPr>
             <a:r>
               <a:rPr lang="en-US" dirty="0"/>
-              <a:t>Can also warm start it with Imitation learning: reward for mimicking the optimizer output</a:t>
+              <a:t>Can also warm start it with Imitation learning: reward for mimicking the optimizer </a:t>
+            </a:r>
+            <a:r>
+              <a:rPr lang="en-US" dirty="0" smtClean="0"/>
+              <a:t>output</a:t>
             </a:r>
           </a:p>
           <a:p>
@@ -15212,7 +15751,38 @@
             </a:pPr>
             <a:r>
               <a:rPr lang="en-US" dirty="0" smtClean="0"/>
-              <a:t>Can also be later extended and train another agent for load tracking(replacing the wrench controller)</a:t>
+              <a:t>Load </a:t>
+            </a:r>
+            <a:r>
+              <a:rPr lang="en-US" dirty="0"/>
+              <a:t>tracking guaranteed by construction (G·N = 0</a:t>
+            </a:r>
+            <a:r>
+              <a:rPr lang="en-US" dirty="0" smtClean="0"/>
+              <a:t>)</a:t>
+            </a:r>
+            <a:endParaRPr lang="ar-EG" dirty="0" smtClean="0"/>
+          </a:p>
+          <a:p>
+            <a:pPr indent="-457200">
+              <a:buSzPts val="3200"/>
+            </a:pPr>
+            <a:r>
+              <a:rPr lang="en-US" dirty="0" smtClean="0"/>
+              <a:t>Doesn’t </a:t>
+            </a:r>
+            <a:r>
+              <a:rPr lang="en-US" dirty="0"/>
+              <a:t>handle desynchronization</a:t>
+            </a:r>
+          </a:p>
+          <a:p>
+            <a:pPr indent="-457200">
+              <a:buSzPts val="3200"/>
+            </a:pPr>
+            <a:r>
+              <a:rPr lang="en-US" dirty="0" smtClean="0"/>
+              <a:t>A possible extension would be adding more terms to the reward function to account for fixed-wings dynamics(e.g. minimum turning radius)</a:t>
             </a:r>
             <a:endParaRPr lang="en-US" dirty="0" smtClean="0"/>
           </a:p>
@@ -15296,7 +15866,415 @@
             </a:pPr>
             <a:r>
               <a:rPr lang="it-IT" dirty="0" smtClean="0"/>
-              <a:t>Candidate RL architectures/Formulations</a:t>
+              <a:t>Candidate RL </a:t>
+            </a:r>
+            <a:r>
+              <a:rPr lang="it-IT" dirty="0" smtClean="0"/>
+              <a:t>architectures/Formulations</a:t>
+            </a:r>
+            <a:r>
+              <a:rPr lang="ar-EG" dirty="0"/>
+              <a:t/>
+            </a:r>
+            <a:br>
+              <a:rPr lang="ar-EG" dirty="0"/>
+            </a:br>
+            <a:r>
+              <a:rPr lang="en-US" dirty="0" smtClean="0"/>
+              <a:t>Formulation </a:t>
+            </a:r>
+            <a:r>
+              <a:rPr lang="ar-EG" dirty="0" smtClean="0"/>
+              <a:t>2</a:t>
+            </a:r>
+            <a:r>
+              <a:rPr lang="en-US" dirty="0" smtClean="0"/>
+              <a:t>:</a:t>
+            </a:r>
+            <a:r>
+              <a:rPr lang="ar-EG" dirty="0" smtClean="0"/>
+              <a:t>  </a:t>
+            </a:r>
+            <a:r>
+              <a:rPr lang="en-US" dirty="0" smtClean="0"/>
+              <a:t>Residual RL</a:t>
+            </a:r>
+            <a:endParaRPr dirty="0"/>
+          </a:p>
+        </p:txBody>
+      </p:sp>
+      <p:sp>
+        <p:nvSpPr>
+          <p:cNvPr id="105" name="Google Shape;105;p2"/>
+          <p:cNvSpPr txBox="1">
+            <a:spLocks noGrp="1"/>
+          </p:cNvSpPr>
+          <p:nvPr>
+            <p:ph type="body" idx="4294967295"/>
+          </p:nvPr>
+        </p:nvSpPr>
+        <p:spPr>
+          <a:xfrm>
+            <a:off x="455999" y="2178768"/>
+            <a:ext cx="11385933" cy="4520796"/>
+          </a:xfrm>
+          <a:prstGeom prst="rect">
+            <a:avLst/>
+          </a:prstGeom>
+          <a:noFill/>
+          <a:ln>
+            <a:noFill/>
+          </a:ln>
+        </p:spPr>
+        <p:txBody>
+          <a:bodyPr spcFirstLastPara="1" wrap="square" lIns="91425" tIns="45700" rIns="91425" bIns="45700" anchor="t" anchorCtr="0">
+            <a:normAutofit fontScale="92500" lnSpcReduction="10000"/>
+          </a:bodyPr>
+          <a:lstStyle/>
+          <a:p>
+            <a:pPr indent="-457200">
+              <a:buSzPts val="3200"/>
+            </a:pPr>
+            <a:r>
+              <a:rPr lang="en-US" dirty="0" smtClean="0"/>
+              <a:t>Action </a:t>
+            </a:r>
+            <a:r>
+              <a:rPr lang="en-US" dirty="0" smtClean="0"/>
+              <a:t>Space: </a:t>
+            </a:r>
+            <a:r>
+              <a:rPr lang="el-GR" dirty="0" smtClean="0"/>
+              <a:t>δ</a:t>
+            </a:r>
+            <a:r>
+              <a:rPr lang="en-US" dirty="0"/>
+              <a:t>𝑓</a:t>
+            </a:r>
+            <a:r>
+              <a:rPr lang="en-US" dirty="0" smtClean="0"/>
+              <a:t> </a:t>
+            </a:r>
+            <a:r>
+              <a:rPr lang="en-US" dirty="0"/>
+              <a:t>∈ </a:t>
+            </a:r>
+            <a:r>
+              <a:rPr lang="en-US" dirty="0" smtClean="0"/>
+              <a:t>R</a:t>
+            </a:r>
+            <a:r>
+              <a:rPr lang="en-US" baseline="30000" dirty="0" smtClean="0"/>
+              <a:t>3n</a:t>
+            </a:r>
+            <a:r>
+              <a:rPr lang="en-US" dirty="0" smtClean="0"/>
+              <a:t> </a:t>
+            </a:r>
+          </a:p>
+          <a:p>
+            <a:pPr lvl="1" indent="-457200">
+              <a:buSzPts val="3200"/>
+            </a:pPr>
+            <a:r>
+              <a:rPr lang="en-US" dirty="0" smtClean="0"/>
+              <a:t>Keep wrench controller and optimizer. Run decentralized</a:t>
+            </a:r>
+          </a:p>
+          <a:p>
+            <a:pPr marL="457200" lvl="1" indent="0">
+              <a:buSzPts val="3200"/>
+              <a:buNone/>
+            </a:pPr>
+            <a:r>
+              <a:rPr lang="en-US" dirty="0" smtClean="0"/>
+              <a:t>				</a:t>
+            </a:r>
+            <a:r>
+              <a:rPr lang="en-US" dirty="0"/>
+              <a:t>𝑓 (𝑡) = 𝑓</a:t>
+            </a:r>
+            <a:r>
+              <a:rPr lang="en-US" baseline="-25000" dirty="0"/>
+              <a:t>𝑔</a:t>
+            </a:r>
+            <a:r>
+              <a:rPr lang="en-US" dirty="0"/>
+              <a:t>(𝑡)+ 𝑓</a:t>
+            </a:r>
+            <a:r>
+              <a:rPr lang="en-US" baseline="-25000" dirty="0"/>
+              <a:t>𝜆</a:t>
+            </a:r>
+            <a:r>
+              <a:rPr lang="en-US" dirty="0"/>
+              <a:t>(𝑡</a:t>
+            </a:r>
+            <a:r>
+              <a:rPr lang="en-US" dirty="0" smtClean="0"/>
+              <a:t>) + </a:t>
+            </a:r>
+            <a:r>
+              <a:rPr lang="el-GR" u="sng" dirty="0" smtClean="0"/>
+              <a:t>δ</a:t>
+            </a:r>
+            <a:r>
+              <a:rPr lang="en-US" u="sng" dirty="0" smtClean="0"/>
+              <a:t>𝑓(t)</a:t>
+            </a:r>
+          </a:p>
+          <a:p>
+            <a:pPr marL="457200" lvl="1" indent="0">
+              <a:buSzPts val="3200"/>
+              <a:buNone/>
+            </a:pPr>
+            <a:endParaRPr lang="en-US" u="sng" dirty="0" smtClean="0"/>
+          </a:p>
+          <a:p>
+            <a:pPr indent="-457200">
+              <a:buSzPts val="3200"/>
+            </a:pPr>
+            <a:r>
+              <a:rPr lang="en-US" dirty="0" smtClean="0"/>
+              <a:t>Reward </a:t>
+            </a:r>
+            <a:r>
+              <a:rPr lang="en-US" dirty="0"/>
+              <a:t>function: </a:t>
+            </a:r>
+          </a:p>
+          <a:p>
+            <a:pPr lvl="1" indent="-457200">
+              <a:buSzPts val="3200"/>
+            </a:pPr>
+            <a:r>
+              <a:rPr lang="en-US" dirty="0"/>
+              <a:t>Penalize load tracking error + Penalize ‖</a:t>
+            </a:r>
+            <a:r>
+              <a:rPr lang="en-US" dirty="0" err="1"/>
+              <a:t>δf</a:t>
+            </a:r>
+            <a:r>
+              <a:rPr lang="en-US" dirty="0" smtClean="0"/>
+              <a:t>‖</a:t>
+            </a:r>
+          </a:p>
+          <a:p>
+            <a:pPr indent="-457200">
+              <a:buSzPts val="3200"/>
+            </a:pPr>
+            <a:r>
+              <a:rPr lang="en-US" dirty="0" smtClean="0"/>
+              <a:t>Handles desynchronization</a:t>
+            </a:r>
+          </a:p>
+          <a:p>
+            <a:pPr lvl="0" indent="-457200">
+              <a:buSzPts val="3200"/>
+            </a:pPr>
+            <a:r>
+              <a:rPr lang="en-US" dirty="0" smtClean="0">
+                <a:solidFill>
+                  <a:schemeClr val="tx1"/>
+                </a:solidFill>
+                <a:latin typeface="Arial" panose="020B0604020202020204" pitchFamily="34" charset="0"/>
+              </a:rPr>
+              <a:t>Stage </a:t>
+            </a:r>
+            <a:r>
+              <a:rPr lang="en-US" dirty="0">
+                <a:solidFill>
+                  <a:schemeClr val="tx1"/>
+                </a:solidFill>
+                <a:latin typeface="Arial" panose="020B0604020202020204" pitchFamily="34" charset="0"/>
+              </a:rPr>
+              <a:t>1: Train formulation </a:t>
+            </a:r>
+            <a:r>
+              <a:rPr lang="en-US" dirty="0" smtClean="0">
+                <a:solidFill>
+                  <a:schemeClr val="tx1"/>
+                </a:solidFill>
+                <a:latin typeface="Arial" panose="020B0604020202020204" pitchFamily="34" charset="0"/>
+              </a:rPr>
+              <a:t>2</a:t>
+            </a:r>
+          </a:p>
+          <a:p>
+            <a:pPr lvl="0" indent="-457200">
+              <a:buSzPts val="3200"/>
+            </a:pPr>
+            <a:r>
+              <a:rPr lang="en-US" dirty="0" smtClean="0">
+                <a:solidFill>
+                  <a:schemeClr val="tx1"/>
+                </a:solidFill>
+                <a:latin typeface="Arial" panose="020B0604020202020204" pitchFamily="34" charset="0"/>
+              </a:rPr>
+              <a:t>Stage 2: </a:t>
+            </a:r>
+            <a:r>
+              <a:rPr lang="en-US" dirty="0">
+                <a:solidFill>
+                  <a:schemeClr val="tx1"/>
+                </a:solidFill>
+                <a:latin typeface="Arial" panose="020B0604020202020204" pitchFamily="34" charset="0"/>
+              </a:rPr>
+              <a:t>Remove optimizer </a:t>
+            </a:r>
+            <a:r>
+              <a:rPr lang="en-US" dirty="0" smtClean="0">
+                <a:solidFill>
+                  <a:schemeClr val="tx1"/>
+                </a:solidFill>
+                <a:latin typeface="Arial" panose="020B0604020202020204" pitchFamily="34" charset="0"/>
+              </a:rPr>
+              <a:t>and train formulation 1</a:t>
+            </a:r>
+            <a:r>
+              <a:rPr lang="ar-EG" dirty="0" smtClean="0">
+                <a:solidFill>
+                  <a:schemeClr val="tx1"/>
+                </a:solidFill>
+                <a:latin typeface="Arial" panose="020B0604020202020204" pitchFamily="34" charset="0"/>
+              </a:rPr>
+              <a:t> </a:t>
+            </a:r>
+            <a:endParaRPr lang="ar-EG" dirty="0">
+              <a:solidFill>
+                <a:schemeClr val="tx1"/>
+              </a:solidFill>
+              <a:latin typeface="Arial" panose="020B0604020202020204" pitchFamily="34" charset="0"/>
+            </a:endParaRPr>
+          </a:p>
+          <a:p>
+            <a:pPr lvl="0" indent="-457200">
+              <a:buSzPts val="3200"/>
+            </a:pPr>
+            <a:r>
+              <a:rPr lang="en-US" dirty="0">
+                <a:solidFill>
+                  <a:schemeClr val="tx1"/>
+                </a:solidFill>
+                <a:latin typeface="Arial" panose="020B0604020202020204" pitchFamily="34" charset="0"/>
+              </a:rPr>
+              <a:t>C</a:t>
+            </a:r>
+            <a:r>
+              <a:rPr lang="en-US" dirty="0" smtClean="0">
+                <a:solidFill>
+                  <a:schemeClr val="tx1"/>
+                </a:solidFill>
+                <a:latin typeface="Arial" panose="020B0604020202020204" pitchFamily="34" charset="0"/>
+              </a:rPr>
+              <a:t>ould also work the other way around(would be better for simulation time) or combined in one phase</a:t>
+            </a:r>
+            <a:endParaRPr lang="en-US" dirty="0">
+              <a:solidFill>
+                <a:schemeClr val="tx1"/>
+              </a:solidFill>
+              <a:latin typeface="Arial" panose="020B0604020202020204" pitchFamily="34" charset="0"/>
+            </a:endParaRPr>
+          </a:p>
+          <a:p>
+            <a:pPr indent="-457200">
+              <a:buSzPts val="3200"/>
+            </a:pPr>
+            <a:endParaRPr lang="en-US" dirty="0" smtClean="0"/>
+          </a:p>
+        </p:txBody>
+      </p:sp>
+    </p:spTree>
+    <p:extLst>
+      <p:ext uri="{BB962C8B-B14F-4D97-AF65-F5344CB8AC3E}">
+        <p14:creationId xmlns:p14="http://schemas.microsoft.com/office/powerpoint/2010/main" val="3986476106"/>
+      </p:ext>
+    </p:extLst>
+  </p:cSld>
+  <p:clrMapOvr>
+    <a:masterClrMapping/>
+  </p:clrMapOvr>
+</p:sld>
+</file>
+
+<file path=ppt/slides/slide6.xml><?xml version="1.0" encoding="utf-8"?>
+<p:sld xmlns:a="http://schemas.openxmlformats.org/drawingml/2006/main" xmlns:r="http://schemas.openxmlformats.org/officeDocument/2006/relationships" xmlns:p="http://schemas.openxmlformats.org/presentationml/2006/main">
+  <p:cSld>
+    <p:spTree>
+      <p:nvGrpSpPr>
+        <p:cNvPr id="1" name="Shape 103"/>
+        <p:cNvGrpSpPr/>
+        <p:nvPr/>
+      </p:nvGrpSpPr>
+      <p:grpSpPr>
+        <a:xfrm>
+          <a:off x="0" y="0"/>
+          <a:ext cx="0" cy="0"/>
+          <a:chOff x="0" y="0"/>
+          <a:chExt cx="0" cy="0"/>
+        </a:xfrm>
+      </p:grpSpPr>
+      <p:sp>
+        <p:nvSpPr>
+          <p:cNvPr id="104" name="Google Shape;104;p2"/>
+          <p:cNvSpPr txBox="1">
+            <a:spLocks noGrp="1"/>
+          </p:cNvSpPr>
+          <p:nvPr>
+            <p:ph type="title"/>
+          </p:nvPr>
+        </p:nvSpPr>
+        <p:spPr>
+          <a:xfrm>
+            <a:off x="456000" y="1142356"/>
+            <a:ext cx="11736000" cy="1188000"/>
+          </a:xfrm>
+          <a:prstGeom prst="rect">
+            <a:avLst/>
+          </a:prstGeom>
+          <a:noFill/>
+          <a:ln>
+            <a:noFill/>
+          </a:ln>
+        </p:spPr>
+        <p:txBody>
+          <a:bodyPr spcFirstLastPara="1" wrap="square" lIns="91425" tIns="45700" rIns="91425" bIns="45700" anchor="ctr" anchorCtr="0">
+            <a:normAutofit/>
+          </a:bodyPr>
+          <a:lstStyle/>
+          <a:p>
+            <a:pPr marL="0" lvl="0" indent="0" algn="l" rtl="0">
+              <a:lnSpc>
+                <a:spcPct val="90000"/>
+              </a:lnSpc>
+              <a:spcBef>
+                <a:spcPts val="0"/>
+              </a:spcBef>
+              <a:spcAft>
+                <a:spcPts val="0"/>
+              </a:spcAft>
+              <a:buClr>
+                <a:schemeClr val="dk1"/>
+              </a:buClr>
+              <a:buSzPts val="3600"/>
+              <a:buFont typeface="Arial"/>
+              <a:buNone/>
+            </a:pPr>
+            <a:r>
+              <a:rPr lang="it-IT" dirty="0" smtClean="0"/>
+              <a:t>Candidate RL </a:t>
+            </a:r>
+            <a:r>
+              <a:rPr lang="it-IT" dirty="0" smtClean="0"/>
+              <a:t>architectures/Formulations</a:t>
+            </a:r>
+            <a:br>
+              <a:rPr lang="it-IT" dirty="0" smtClean="0"/>
+            </a:br>
+            <a:r>
+              <a:rPr lang="it-IT" dirty="0" smtClean="0"/>
+              <a:t>Another approach</a:t>
             </a:r>
             <a:endParaRPr dirty="0"/>
           </a:p>
@@ -15427,17 +16405,12 @@
             </a:pPr>
             <a:r>
               <a:rPr lang="en-US" sz="2400" dirty="0" smtClean="0"/>
-              <a:t>In both cases we start ideal, then progressively add noise, </a:t>
-            </a:r>
-            <a:r>
-              <a:rPr lang="en-US" sz="2400" dirty="0" err="1" smtClean="0"/>
-              <a:t>desynchronization</a:t>
+              <a:t>Start </a:t>
             </a:r>
             <a:r>
               <a:rPr lang="en-US" sz="2400" dirty="0" smtClean="0"/>
-              <a:t> and domain randomization </a:t>
-            </a:r>
-            <a:endParaRPr lang="en-US" sz="2400" dirty="0" smtClean="0"/>
+              <a:t>ideal, then progressively add noise, desynchronization and domain randomization </a:t>
+            </a:r>
           </a:p>
         </p:txBody>
       </p:sp>
@@ -15447,176 +16420,6 @@
         <p14:creationId xmlns:p14="http://schemas.microsoft.com/office/powerpoint/2010/main" val="4164796720"/>
       </p:ext>
     </p:extLst>
-  </p:cSld>
-  <p:clrMapOvr>
-    <a:masterClrMapping/>
-  </p:clrMapOvr>
-</p:sld>
-</file>
-
-<file path=ppt/slides/slide6.xml><?xml version="1.0" encoding="utf-8"?>
-<p:sld xmlns:a="http://schemas.openxmlformats.org/drawingml/2006/main" xmlns:r="http://schemas.openxmlformats.org/officeDocument/2006/relationships" xmlns:p="http://schemas.openxmlformats.org/presentationml/2006/main">
-  <p:cSld>
-    <p:spTree>
-      <p:nvGrpSpPr>
-        <p:cNvPr id="1" name="Shape 110"/>
-        <p:cNvGrpSpPr/>
-        <p:nvPr/>
-      </p:nvGrpSpPr>
-      <p:grpSpPr>
-        <a:xfrm>
-          <a:off x="0" y="0"/>
-          <a:ext cx="0" cy="0"/>
-          <a:chOff x="0" y="0"/>
-          <a:chExt cx="0" cy="0"/>
-        </a:xfrm>
-      </p:grpSpPr>
-      <p:sp>
-        <p:nvSpPr>
-          <p:cNvPr id="111" name="Google Shape;111;p3"/>
-          <p:cNvSpPr txBox="1">
-            <a:spLocks noGrp="1"/>
-          </p:cNvSpPr>
-          <p:nvPr>
-            <p:ph type="title"/>
-          </p:nvPr>
-        </p:nvSpPr>
-        <p:spPr>
-          <a:xfrm>
-            <a:off x="456000" y="1160463"/>
-            <a:ext cx="11736000" cy="1188000"/>
-          </a:xfrm>
-          <a:prstGeom prst="rect">
-            <a:avLst/>
-          </a:prstGeom>
-          <a:noFill/>
-          <a:ln>
-            <a:noFill/>
-          </a:ln>
-        </p:spPr>
-        <p:txBody>
-          <a:bodyPr spcFirstLastPara="1" wrap="square" lIns="91425" tIns="45700" rIns="91425" bIns="45700" anchor="ctr" anchorCtr="0">
-            <a:noAutofit/>
-          </a:bodyPr>
-          <a:lstStyle/>
-          <a:p>
-            <a:pPr lvl="0"/>
-            <a:r>
-              <a:rPr lang="it-IT" dirty="0"/>
-              <a:t>Candidate RL architectures/Formulations</a:t>
-            </a:r>
-            <a:endParaRPr dirty="0"/>
-          </a:p>
-        </p:txBody>
-      </p:sp>
-      <p:sp>
-        <p:nvSpPr>
-          <p:cNvPr id="112" name="Google Shape;112;p3"/>
-          <p:cNvSpPr txBox="1">
-            <a:spLocks noGrp="1"/>
-          </p:cNvSpPr>
-          <p:nvPr>
-            <p:ph type="body" idx="4294967295"/>
-          </p:nvPr>
-        </p:nvSpPr>
-        <p:spPr>
-          <a:xfrm>
-            <a:off x="456000" y="2221759"/>
-            <a:ext cx="11381961" cy="3879538"/>
-          </a:xfrm>
-          <a:prstGeom prst="rect">
-            <a:avLst/>
-          </a:prstGeom>
-          <a:noFill/>
-          <a:ln>
-            <a:noFill/>
-          </a:ln>
-        </p:spPr>
-        <p:txBody>
-          <a:bodyPr spcFirstLastPara="1" wrap="square" lIns="91425" tIns="45700" rIns="91425" bIns="45700" anchor="t" anchorCtr="0">
-            <a:normAutofit fontScale="92500" lnSpcReduction="10000"/>
-          </a:bodyPr>
-          <a:lstStyle/>
-          <a:p>
-            <a:pPr indent="-457200"/>
-            <a:r>
-              <a:rPr lang="en-US" dirty="0" smtClean="0"/>
-              <a:t>Wrap FMU inside Gym environment </a:t>
-            </a:r>
-          </a:p>
-          <a:p>
-            <a:pPr indent="-457200"/>
-            <a:r>
-              <a:rPr lang="en-US" dirty="0" smtClean="0"/>
-              <a:t>Centralized Training Decentralized Execution (CTDE)</a:t>
-            </a:r>
-          </a:p>
-          <a:p>
-            <a:pPr indent="-457200"/>
-            <a:r>
-              <a:rPr lang="en-US" dirty="0" smtClean="0"/>
-              <a:t>Shared/Centralized critic with access to global state with </a:t>
-            </a:r>
-            <a:r>
-              <a:rPr lang="en-US" dirty="0"/>
-              <a:t>a Parameter-Shared </a:t>
-            </a:r>
-            <a:r>
-              <a:rPr lang="en-US" dirty="0" smtClean="0"/>
-              <a:t>decentralized Actor</a:t>
-            </a:r>
-            <a:endParaRPr lang="en-US" dirty="0"/>
-          </a:p>
-          <a:p>
-            <a:pPr indent="-457200"/>
-            <a:r>
-              <a:rPr lang="en-US" dirty="0"/>
-              <a:t>Multi-Agent Proximal Policy Optimization (MAPPO</a:t>
-            </a:r>
-            <a:r>
-              <a:rPr lang="en-US" dirty="0" smtClean="0"/>
-              <a:t>) </a:t>
-            </a:r>
-          </a:p>
-          <a:p>
-            <a:pPr indent="-457200"/>
-            <a:endParaRPr lang="en-US" dirty="0" smtClean="0"/>
-          </a:p>
-          <a:p>
-            <a:pPr indent="-457200"/>
-            <a:endParaRPr lang="en-US" dirty="0"/>
-          </a:p>
-          <a:p>
-            <a:pPr marL="0" indent="0">
-              <a:buNone/>
-            </a:pPr>
-            <a:r>
-              <a:rPr lang="en-US" dirty="0" smtClean="0"/>
-              <a:t>These choices(at least as a starting point) are due to their </a:t>
-            </a:r>
-            <a:r>
-              <a:rPr lang="en-US" dirty="0"/>
-              <a:t>widespread adoption across cooperative multi-agent </a:t>
-            </a:r>
-            <a:r>
-              <a:rPr lang="en-US" dirty="0" smtClean="0"/>
-              <a:t>literature</a:t>
-            </a:r>
-            <a:endParaRPr lang="en-US" dirty="0"/>
-          </a:p>
-          <a:p>
-            <a:pPr indent="-457200"/>
-            <a:endParaRPr lang="en-US" dirty="0"/>
-          </a:p>
-          <a:p>
-            <a:pPr marL="0" indent="0">
-              <a:buNone/>
-            </a:pPr>
-            <a:endParaRPr dirty="0"/>
-          </a:p>
-        </p:txBody>
-      </p:sp>
-    </p:spTree>
   </p:cSld>
   <p:clrMapOvr>
     <a:masterClrMapping/>
@@ -15670,6 +16473,207 @@
           </a:bodyPr>
           <a:lstStyle/>
           <a:p>
+            <a:pPr lvl="0"/>
+            <a:r>
+              <a:rPr lang="it-IT" dirty="0"/>
+              <a:t>Candidate RL architectures/Formulations</a:t>
+            </a:r>
+            <a:endParaRPr dirty="0"/>
+          </a:p>
+        </p:txBody>
+      </p:sp>
+      <p:sp>
+        <p:nvSpPr>
+          <p:cNvPr id="112" name="Google Shape;112;p3"/>
+          <p:cNvSpPr txBox="1">
+            <a:spLocks noGrp="1"/>
+          </p:cNvSpPr>
+          <p:nvPr>
+            <p:ph type="body" idx="4294967295"/>
+          </p:nvPr>
+        </p:nvSpPr>
+        <p:spPr>
+          <a:xfrm>
+            <a:off x="456000" y="2221759"/>
+            <a:ext cx="11381961" cy="4332950"/>
+          </a:xfrm>
+          <a:prstGeom prst="rect">
+            <a:avLst/>
+          </a:prstGeom>
+          <a:noFill/>
+          <a:ln>
+            <a:noFill/>
+          </a:ln>
+        </p:spPr>
+        <p:txBody>
+          <a:bodyPr spcFirstLastPara="1" wrap="square" lIns="91425" tIns="45700" rIns="91425" bIns="45700" anchor="t" anchorCtr="0">
+            <a:normAutofit fontScale="92500" lnSpcReduction="20000"/>
+          </a:bodyPr>
+          <a:lstStyle/>
+          <a:p>
+            <a:pPr indent="-457200"/>
+            <a:r>
+              <a:rPr lang="en-US" dirty="0" smtClean="0"/>
+              <a:t>Wrap FMU inside Gym environment </a:t>
+            </a:r>
+          </a:p>
+          <a:p>
+            <a:pPr indent="-457200"/>
+            <a:r>
+              <a:rPr lang="en-US" dirty="0" smtClean="0"/>
+              <a:t>Centralized Training Decentralized Execution (CTDE</a:t>
+            </a:r>
+            <a:r>
+              <a:rPr lang="en-US" dirty="0" smtClean="0"/>
+              <a:t>)*</a:t>
+            </a:r>
+            <a:endParaRPr lang="en-US" dirty="0" smtClean="0"/>
+          </a:p>
+          <a:p>
+            <a:pPr indent="-457200"/>
+            <a:r>
+              <a:rPr lang="en-US" dirty="0" smtClean="0"/>
+              <a:t>Shared/Centralized critic with access to global state with </a:t>
+            </a:r>
+            <a:r>
+              <a:rPr lang="en-US" dirty="0"/>
+              <a:t>a Parameter-Shared </a:t>
+            </a:r>
+            <a:r>
+              <a:rPr lang="en-US" dirty="0" smtClean="0"/>
+              <a:t>decentralized Actor</a:t>
+            </a:r>
+            <a:endParaRPr lang="en-US" dirty="0"/>
+          </a:p>
+          <a:p>
+            <a:pPr indent="-457200"/>
+            <a:r>
+              <a:rPr lang="en-US" dirty="0"/>
+              <a:t>Multi-Agent Proximal Policy Optimization (MAPPO</a:t>
+            </a:r>
+            <a:r>
+              <a:rPr lang="en-US" dirty="0" smtClean="0"/>
+              <a:t>) </a:t>
+            </a:r>
+          </a:p>
+          <a:p>
+            <a:pPr indent="-457200"/>
+            <a:endParaRPr lang="en-US" dirty="0" smtClean="0"/>
+          </a:p>
+          <a:p>
+            <a:pPr indent="-457200"/>
+            <a:endParaRPr lang="en-US" dirty="0"/>
+          </a:p>
+          <a:p>
+            <a:pPr indent="-457200">
+              <a:buFont typeface="Wingdings" panose="05000000000000000000" pitchFamily="2" charset="2"/>
+              <a:buChar char="§"/>
+            </a:pPr>
+            <a:r>
+              <a:rPr lang="en-US" dirty="0" smtClean="0"/>
+              <a:t>These choices(at least as a starting point) are due to their </a:t>
+            </a:r>
+            <a:r>
+              <a:rPr lang="en-US" dirty="0"/>
+              <a:t>widespread adoption across cooperative multi-agent </a:t>
+            </a:r>
+            <a:r>
+              <a:rPr lang="en-US" dirty="0" smtClean="0"/>
+              <a:t>literature</a:t>
+            </a:r>
+          </a:p>
+          <a:p>
+            <a:pPr marL="0" indent="0">
+              <a:buNone/>
+            </a:pPr>
+            <a:r>
+              <a:rPr lang="en-US" dirty="0" smtClean="0"/>
+              <a:t>*Can </a:t>
+            </a:r>
+            <a:r>
+              <a:rPr lang="en-US" dirty="0"/>
+              <a:t>be </a:t>
+            </a:r>
+            <a:r>
+              <a:rPr lang="en-US" dirty="0" smtClean="0"/>
+              <a:t>a fully </a:t>
+            </a:r>
+            <a:r>
+              <a:rPr lang="en-US" dirty="0"/>
+              <a:t>decentralized </a:t>
+            </a:r>
+            <a:r>
+              <a:rPr lang="en-US" dirty="0" smtClean="0"/>
+              <a:t>actor-critic if we only care about the agent velocity norm(formulation 1)</a:t>
+            </a:r>
+            <a:endParaRPr lang="en-US" dirty="0"/>
+          </a:p>
+          <a:p>
+            <a:pPr indent="-457200"/>
+            <a:endParaRPr lang="en-US" dirty="0"/>
+          </a:p>
+          <a:p>
+            <a:pPr marL="0" indent="0">
+              <a:buNone/>
+            </a:pPr>
+            <a:endParaRPr dirty="0"/>
+          </a:p>
+        </p:txBody>
+      </p:sp>
+    </p:spTree>
+  </p:cSld>
+  <p:clrMapOvr>
+    <a:masterClrMapping/>
+  </p:clrMapOvr>
+</p:sld>
+</file>
+
+<file path=ppt/slides/slide8.xml><?xml version="1.0" encoding="utf-8"?>
+<p:sld xmlns:a="http://schemas.openxmlformats.org/drawingml/2006/main" xmlns:r="http://schemas.openxmlformats.org/officeDocument/2006/relationships" xmlns:p="http://schemas.openxmlformats.org/presentationml/2006/main">
+  <p:cSld>
+    <p:spTree>
+      <p:nvGrpSpPr>
+        <p:cNvPr id="1" name="Shape 110"/>
+        <p:cNvGrpSpPr/>
+        <p:nvPr/>
+      </p:nvGrpSpPr>
+      <p:grpSpPr>
+        <a:xfrm>
+          <a:off x="0" y="0"/>
+          <a:ext cx="0" cy="0"/>
+          <a:chOff x="0" y="0"/>
+          <a:chExt cx="0" cy="0"/>
+        </a:xfrm>
+      </p:grpSpPr>
+      <p:sp>
+        <p:nvSpPr>
+          <p:cNvPr id="111" name="Google Shape;111;p3"/>
+          <p:cNvSpPr txBox="1">
+            <a:spLocks noGrp="1"/>
+          </p:cNvSpPr>
+          <p:nvPr>
+            <p:ph type="title"/>
+          </p:nvPr>
+        </p:nvSpPr>
+        <p:spPr>
+          <a:xfrm>
+            <a:off x="456000" y="1160463"/>
+            <a:ext cx="11736000" cy="1188000"/>
+          </a:xfrm>
+          <a:prstGeom prst="rect">
+            <a:avLst/>
+          </a:prstGeom>
+          <a:noFill/>
+          <a:ln>
+            <a:noFill/>
+          </a:ln>
+        </p:spPr>
+        <p:txBody>
+          <a:bodyPr spcFirstLastPara="1" wrap="square" lIns="91425" tIns="45700" rIns="91425" bIns="45700" anchor="ctr" anchorCtr="0">
+            <a:noAutofit/>
+          </a:bodyPr>
+          <a:lstStyle/>
+          <a:p>
             <a:pPr marL="0" lvl="0" indent="0" algn="l" rtl="0">
               <a:lnSpc>
                 <a:spcPct val="90000"/>
@@ -15720,107 +16724,140 @@
         </p:spPr>
         <p:txBody>
           <a:bodyPr spcFirstLastPara="1" wrap="square" lIns="91425" tIns="45700" rIns="91425" bIns="45700" anchor="t" anchorCtr="0">
-            <a:normAutofit lnSpcReduction="10000"/>
+            <a:normAutofit fontScale="92500" lnSpcReduction="20000"/>
           </a:bodyPr>
           <a:lstStyle/>
           <a:p>
             <a:pPr indent="-457200"/>
             <a:r>
-              <a:rPr lang="en-US" smtClean="0"/>
+              <a:rPr lang="en-US" dirty="0" smtClean="0"/>
               <a:t>Are the desired forces injected directly into the cables?</a:t>
             </a:r>
           </a:p>
           <a:p>
             <a:pPr indent="-457200"/>
             <a:r>
-              <a:rPr lang="en-US" smtClean="0"/>
-              <a:t>Do we calculate RL by just integrating RL_dot</a:t>
-            </a:r>
+              <a:rPr lang="en-US" dirty="0" smtClean="0"/>
+              <a:t>Do we calculate RL by just integrating </a:t>
+            </a:r>
+            <a:r>
+              <a:rPr lang="en-US" dirty="0" err="1" smtClean="0"/>
+              <a:t>RL_dot</a:t>
+            </a:r>
+            <a:endParaRPr lang="en-US" dirty="0" smtClean="0"/>
           </a:p>
           <a:p>
             <a:pPr indent="-457200"/>
             <a:r>
-              <a:rPr lang="en-US" smtClean="0"/>
-              <a:t>Static controller initialization of Fg</a:t>
-            </a:r>
+              <a:rPr lang="en-US" dirty="0" smtClean="0"/>
+              <a:t>Static controller initialization of </a:t>
+            </a:r>
+            <a:r>
+              <a:rPr lang="en-US" dirty="0" err="1" smtClean="0"/>
+              <a:t>Fg</a:t>
+            </a:r>
+            <a:endParaRPr lang="en-US" dirty="0" smtClean="0"/>
           </a:p>
           <a:p>
             <a:pPr indent="-457200"/>
             <a:r>
-              <a:rPr lang="en-US" smtClean="0"/>
+              <a:rPr lang="en-US" dirty="0" smtClean="0"/>
               <a:t>How </a:t>
             </a:r>
             <a:r>
-              <a:rPr lang="en-US"/>
-              <a:t>does load go back to x,y origin in the </a:t>
-            </a:r>
-            <a:r>
-              <a:rPr lang="en-US" smtClean="0"/>
+              <a:rPr lang="en-US" dirty="0"/>
+              <a:t>does load go back to </a:t>
+            </a:r>
+            <a:r>
+              <a:rPr lang="en-US" dirty="0" err="1"/>
+              <a:t>x,y</a:t>
+            </a:r>
+            <a:r>
+              <a:rPr lang="en-US" dirty="0"/>
+              <a:t> origin in the </a:t>
+            </a:r>
+            <a:r>
+              <a:rPr lang="en-US" dirty="0" smtClean="0"/>
               <a:t>2a(no feedback)?</a:t>
             </a:r>
           </a:p>
           <a:p>
             <a:pPr indent="-457200"/>
             <a:r>
-              <a:rPr lang="en-US"/>
-              <a:t>Attachment points </a:t>
-            </a:r>
-            <a:r>
-              <a:rPr lang="en-US" smtClean="0"/>
-              <a:t>and their effect</a:t>
+              <a:rPr lang="en-US" dirty="0"/>
+              <a:t>Attachment </a:t>
+            </a:r>
+            <a:r>
+              <a:rPr lang="en-US" dirty="0" smtClean="0"/>
+              <a:t>points and their effect</a:t>
             </a:r>
           </a:p>
           <a:p>
             <a:pPr indent="-457200"/>
             <a:r>
-              <a:rPr lang="en-US" smtClean="0"/>
-              <a:t>Wpos </a:t>
-            </a:r>
-            <a:r>
-              <a:rPr lang="en-US"/>
+              <a:rPr lang="en-US" dirty="0" smtClean="0"/>
+              <a:t>Which Hamiltonian cycle</a:t>
+            </a:r>
+          </a:p>
+          <a:p>
+            <a:pPr indent="-457200"/>
+            <a:r>
+              <a:rPr lang="en-US" dirty="0" err="1" smtClean="0"/>
+              <a:t>Wpos</a:t>
+            </a:r>
+            <a:r>
+              <a:rPr lang="en-US" dirty="0" smtClean="0"/>
+              <a:t> </a:t>
+            </a:r>
+            <a:r>
+              <a:rPr lang="en-US" dirty="0"/>
               <a:t>and </a:t>
             </a:r>
             <a:r>
-              <a:rPr lang="en-US" smtClean="0"/>
-              <a:t>Wvel </a:t>
-            </a:r>
-            <a:r>
-              <a:rPr lang="en-US"/>
+              <a:rPr lang="en-US" dirty="0" err="1" smtClean="0"/>
+              <a:t>Wvel</a:t>
+            </a:r>
+            <a:r>
+              <a:rPr lang="en-US" dirty="0" smtClean="0"/>
+              <a:t> </a:t>
+            </a:r>
+            <a:r>
+              <a:rPr lang="en-US" dirty="0"/>
               <a:t>are harmful</a:t>
             </a:r>
             <a:r>
-              <a:rPr lang="en-US" smtClean="0"/>
+              <a:rPr lang="en-US" dirty="0" smtClean="0"/>
               <a:t>?</a:t>
             </a:r>
           </a:p>
           <a:p>
             <a:pPr indent="-457200"/>
             <a:r>
-              <a:rPr lang="en-US" smtClean="0"/>
+              <a:rPr lang="en-US" dirty="0" smtClean="0"/>
               <a:t>Low level controller </a:t>
             </a:r>
           </a:p>
           <a:p>
             <a:pPr indent="-457200"/>
             <a:r>
-              <a:rPr lang="en-US" smtClean="0"/>
+              <a:rPr lang="en-US" dirty="0" smtClean="0"/>
               <a:t>Optimizer just makes the drone fly in a straight line</a:t>
             </a:r>
-            <a:endParaRPr lang="en-US"/>
+            <a:endParaRPr lang="en-US" dirty="0"/>
           </a:p>
           <a:p>
             <a:pPr indent="-457200"/>
-            <a:endParaRPr lang="en-US"/>
+            <a:endParaRPr lang="en-US" dirty="0"/>
           </a:p>
           <a:p>
             <a:pPr indent="-457200"/>
-            <a:endParaRPr lang="en-US"/>
+            <a:endParaRPr lang="en-US" dirty="0"/>
           </a:p>
           <a:p>
             <a:pPr marL="0" indent="0">
               <a:buNone/>
             </a:pPr>
-            <a:endParaRPr/>
+            <a:endParaRPr dirty="0"/>
           </a:p>
         </p:txBody>
       </p:sp>
@@ -15837,7 +16874,7 @@
 </p:sld>
 </file>
 
-<file path=ppt/slides/slide8.xml><?xml version="1.0" encoding="utf-8"?>
+<file path=ppt/slides/slide9.xml><?xml version="1.0" encoding="utf-8"?>
 <p:sld xmlns:a="http://schemas.openxmlformats.org/drawingml/2006/main" xmlns:r="http://schemas.openxmlformats.org/officeDocument/2006/relationships" xmlns:p="http://schemas.openxmlformats.org/presentationml/2006/main">
   <p:cSld>
     <p:spTree>
@@ -16324,85 +17361,6 @@
         <p14:creationId xmlns:p14="http://schemas.microsoft.com/office/powerpoint/2010/main" val="3955177555"/>
       </p:ext>
     </p:extLst>
-  </p:cSld>
-  <p:clrMapOvr>
-    <a:masterClrMapping/>
-  </p:clrMapOvr>
-</p:sld>
-</file>
-
-<file path=ppt/slides/slide9.xml><?xml version="1.0" encoding="utf-8"?>
-<p:sld xmlns:a="http://schemas.openxmlformats.org/drawingml/2006/main" xmlns:r="http://schemas.openxmlformats.org/officeDocument/2006/relationships" xmlns:p="http://schemas.openxmlformats.org/presentationml/2006/main">
-  <p:cSld>
-    <p:spTree>
-      <p:nvGrpSpPr>
-        <p:cNvPr id="1" name="Shape 178"/>
-        <p:cNvGrpSpPr/>
-        <p:nvPr/>
-      </p:nvGrpSpPr>
-      <p:grpSpPr>
-        <a:xfrm>
-          <a:off x="0" y="0"/>
-          <a:ext cx="0" cy="0"/>
-          <a:chOff x="0" y="0"/>
-          <a:chExt cx="0" cy="0"/>
-        </a:xfrm>
-      </p:grpSpPr>
-      <p:sp>
-        <p:nvSpPr>
-          <p:cNvPr id="179" name="Google Shape;179;p14"/>
-          <p:cNvSpPr txBox="1">
-            <a:spLocks noGrp="1"/>
-          </p:cNvSpPr>
-          <p:nvPr>
-            <p:ph type="title" idx="4294967295"/>
-          </p:nvPr>
-        </p:nvSpPr>
-        <p:spPr>
-          <a:xfrm>
-            <a:off x="838200" y="-1325563"/>
-            <a:ext cx="10515600" cy="1325563"/>
-          </a:xfrm>
-          <a:prstGeom prst="rect">
-            <a:avLst/>
-          </a:prstGeom>
-          <a:noFill/>
-          <a:ln>
-            <a:noFill/>
-          </a:ln>
-        </p:spPr>
-        <p:txBody>
-          <a:bodyPr spcFirstLastPara="1" wrap="square" lIns="91425" tIns="45700" rIns="91425" bIns="45700" anchor="b" anchorCtr="0">
-            <a:normAutofit/>
-          </a:bodyPr>
-          <a:lstStyle/>
-          <a:p>
-            <a:pPr marL="0" lvl="0" indent="0" algn="ctr" rtl="0">
-              <a:lnSpc>
-                <a:spcPct val="90000"/>
-              </a:lnSpc>
-              <a:spcBef>
-                <a:spcPts val="0"/>
-              </a:spcBef>
-              <a:spcAft>
-                <a:spcPts val="0"/>
-              </a:spcAft>
-              <a:buClr>
-                <a:schemeClr val="dk1"/>
-              </a:buClr>
-              <a:buSzPts val="4400"/>
-              <a:buFont typeface="Arial"/>
-              <a:buNone/>
-            </a:pPr>
-            <a:r>
-              <a:rPr lang="it-IT"/>
-              <a:t>Università degli Studi di Padova</a:t>
-            </a:r>
-            <a:endParaRPr/>
-          </a:p>
-        </p:txBody>
-      </p:sp>
-    </p:spTree>
   </p:cSld>
   <p:clrMapOvr>
     <a:masterClrMapping/>

</xml_diff>